<commit_message>
Upgrade VERDICT with advanced verification features
</commit_message>
<xml_diff>
--- a/data/demo_files/demo_presentation.pptx
+++ b/data/demo_files/demo_presentation.pptx
@@ -3106,7 +3106,7 @@
           <a:lstStyle/>
           <a:p>
             <a:r>
-              <a:t>Cygnix Executive Strategy 2026</a:t>
+              <a:t>Corporate Strategic Plan</a:t>
             </a:r>
           </a:p>
         </p:txBody>
@@ -3127,7 +3127,7 @@
           <a:lstStyle/>
           <a:p>
             <a:r>
-              <a:t>Trustworthy AI Verification Infrastructure</a:t>
+              <a:t>AI Verification &amp; Evidence Infrastructure</a:t>
             </a:r>
           </a:p>
         </p:txBody>

</xml_diff>